<commit_message>
mudei o nome da apresentação final
</commit_message>
<xml_diff>
--- a/documentos/Apresentação Final do Projeto.pptx
+++ b/documentos/Apresentação Final do Projeto.pptx
@@ -256,7 +256,7 @@
   </p:defaultTextStyle>
   <p:extLst>
     <p:ext uri="GoogleSlidesCustomDataVersion2">
-      <go:slidesCustomData xmlns:go="http://customooxmlschemas.google.com/" r:id="rId14" roundtripDataSignature="AMtx7mgAR1MEciNpGaqDigpQwYaHE4oKNg=="/>
+      <go:slidesCustomData xmlns:go="http://customooxmlschemas.google.com/" r:id="rId14" roundtripDataSignature="AMtx7mgzm8NVh08+MBzM6fFzbab3Bhrp4w=="/>
     </p:ext>
   </p:extLst>
 </p:presentation>
@@ -1860,7 +1860,7 @@
   <p:cSld>
     <p:spTree>
       <p:nvGrpSpPr>
-        <p:cNvPr id="95" name="Shape 95"/>
+        <p:cNvPr id="100" name="Shape 100"/>
         <p:cNvGrpSpPr/>
         <p:nvPr/>
       </p:nvGrpSpPr>
@@ -1874,7 +1874,7 @@
       </p:grpSpPr>
       <p:sp>
         <p:nvSpPr>
-          <p:cNvPr id="96" name="Google Shape;96;p2:notes"/>
+          <p:cNvPr id="101" name="Google Shape;101;p2:notes"/>
           <p:cNvSpPr/>
           <p:nvPr>
             <p:ph idx="2" type="sldImg"/>
@@ -1919,7 +1919,7 @@
       </p:sp>
       <p:sp>
         <p:nvSpPr>
-          <p:cNvPr id="97" name="Google Shape;97;p2:notes"/>
+          <p:cNvPr id="102" name="Google Shape;102;p2:notes"/>
           <p:cNvSpPr txBox="1"/>
           <p:nvPr>
             <p:ph idx="1" type="body"/>
@@ -1966,7 +1966,7 @@
       </p:sp>
       <p:sp>
         <p:nvSpPr>
-          <p:cNvPr id="98" name="Google Shape;98;p2:notes"/>
+          <p:cNvPr id="103" name="Google Shape;103;p2:notes"/>
           <p:cNvSpPr txBox="1"/>
           <p:nvPr>
             <p:ph idx="12" type="sldNum"/>
@@ -2025,7 +2025,7 @@
   <p:cSld>
     <p:spTree>
       <p:nvGrpSpPr>
-        <p:cNvPr id="111" name="Shape 111"/>
+        <p:cNvPr id="116" name="Shape 116"/>
         <p:cNvGrpSpPr/>
         <p:nvPr/>
       </p:nvGrpSpPr>
@@ -2039,7 +2039,7 @@
       </p:grpSpPr>
       <p:sp>
         <p:nvSpPr>
-          <p:cNvPr id="112" name="Google Shape;112;p3:notes"/>
+          <p:cNvPr id="117" name="Google Shape;117;p3:notes"/>
           <p:cNvSpPr/>
           <p:nvPr>
             <p:ph idx="2" type="sldImg"/>
@@ -2084,7 +2084,7 @@
       </p:sp>
       <p:sp>
         <p:nvSpPr>
-          <p:cNvPr id="113" name="Google Shape;113;p3:notes"/>
+          <p:cNvPr id="118" name="Google Shape;118;p3:notes"/>
           <p:cNvSpPr txBox="1"/>
           <p:nvPr>
             <p:ph idx="1" type="body"/>
@@ -2150,7 +2150,7 @@
       </p:sp>
       <p:sp>
         <p:nvSpPr>
-          <p:cNvPr id="114" name="Google Shape;114;p3:notes"/>
+          <p:cNvPr id="119" name="Google Shape;119;p3:notes"/>
           <p:cNvSpPr txBox="1"/>
           <p:nvPr>
             <p:ph idx="12" type="sldNum"/>
@@ -2209,7 +2209,7 @@
   <p:cSld>
     <p:spTree>
       <p:nvGrpSpPr>
-        <p:cNvPr id="130" name="Shape 130"/>
+        <p:cNvPr id="135" name="Shape 135"/>
         <p:cNvGrpSpPr/>
         <p:nvPr/>
       </p:nvGrpSpPr>
@@ -2223,7 +2223,7 @@
       </p:grpSpPr>
       <p:sp>
         <p:nvSpPr>
-          <p:cNvPr id="131" name="Google Shape;131;p4:notes"/>
+          <p:cNvPr id="136" name="Google Shape;136;p4:notes"/>
           <p:cNvSpPr/>
           <p:nvPr>
             <p:ph idx="2" type="sldImg"/>
@@ -2268,7 +2268,7 @@
       </p:sp>
       <p:sp>
         <p:nvSpPr>
-          <p:cNvPr id="132" name="Google Shape;132;p4:notes"/>
+          <p:cNvPr id="137" name="Google Shape;137;p4:notes"/>
           <p:cNvSpPr txBox="1"/>
           <p:nvPr>
             <p:ph idx="1" type="body"/>
@@ -2315,7 +2315,7 @@
       </p:sp>
       <p:sp>
         <p:nvSpPr>
-          <p:cNvPr id="133" name="Google Shape;133;p4:notes"/>
+          <p:cNvPr id="138" name="Google Shape;138;p4:notes"/>
           <p:cNvSpPr txBox="1"/>
           <p:nvPr>
             <p:ph idx="12" type="sldNum"/>
@@ -2374,7 +2374,7 @@
   <p:cSld>
     <p:spTree>
       <p:nvGrpSpPr>
-        <p:cNvPr id="150" name="Shape 150"/>
+        <p:cNvPr id="159" name="Shape 159"/>
         <p:cNvGrpSpPr/>
         <p:nvPr/>
       </p:nvGrpSpPr>
@@ -2388,7 +2388,7 @@
       </p:grpSpPr>
       <p:sp>
         <p:nvSpPr>
-          <p:cNvPr id="151" name="Google Shape;151;p5:notes"/>
+          <p:cNvPr id="160" name="Google Shape;160;p5:notes"/>
           <p:cNvSpPr/>
           <p:nvPr>
             <p:ph idx="2" type="sldImg"/>
@@ -2433,7 +2433,7 @@
       </p:sp>
       <p:sp>
         <p:nvSpPr>
-          <p:cNvPr id="152" name="Google Shape;152;p5:notes"/>
+          <p:cNvPr id="161" name="Google Shape;161;p5:notes"/>
           <p:cNvSpPr txBox="1"/>
           <p:nvPr>
             <p:ph idx="1" type="body"/>
@@ -2480,7 +2480,7 @@
       </p:sp>
       <p:sp>
         <p:nvSpPr>
-          <p:cNvPr id="153" name="Google Shape;153;p5:notes"/>
+          <p:cNvPr id="162" name="Google Shape;162;p5:notes"/>
           <p:cNvSpPr txBox="1"/>
           <p:nvPr>
             <p:ph idx="12" type="sldNum"/>
@@ -2539,7 +2539,7 @@
   <p:cSld>
     <p:spTree>
       <p:nvGrpSpPr>
-        <p:cNvPr id="162" name="Shape 162"/>
+        <p:cNvPr id="171" name="Shape 171"/>
         <p:cNvGrpSpPr/>
         <p:nvPr/>
       </p:nvGrpSpPr>
@@ -2553,7 +2553,7 @@
       </p:grpSpPr>
       <p:sp>
         <p:nvSpPr>
-          <p:cNvPr id="163" name="Google Shape;163;g3c425a62f68_0_0:notes"/>
+          <p:cNvPr id="172" name="Google Shape;172;g3c425a62f68_0_0:notes"/>
           <p:cNvSpPr/>
           <p:nvPr>
             <p:ph idx="2" type="sldImg"/>
@@ -2598,7 +2598,7 @@
       </p:sp>
       <p:sp>
         <p:nvSpPr>
-          <p:cNvPr id="164" name="Google Shape;164;g3c425a62f68_0_0:notes"/>
+          <p:cNvPr id="173" name="Google Shape;173;g3c425a62f68_0_0:notes"/>
           <p:cNvSpPr txBox="1"/>
           <p:nvPr>
             <p:ph idx="1" type="body"/>
@@ -2646,7 +2646,7 @@
       </p:sp>
       <p:sp>
         <p:nvSpPr>
-          <p:cNvPr id="165" name="Google Shape;165;g3c425a62f68_0_0:notes"/>
+          <p:cNvPr id="174" name="Google Shape;174;g3c425a62f68_0_0:notes"/>
           <p:cNvSpPr txBox="1"/>
           <p:nvPr>
             <p:ph idx="12" type="sldNum"/>
@@ -2705,7 +2705,7 @@
   <p:cSld>
     <p:spTree>
       <p:nvGrpSpPr>
-        <p:cNvPr id="168" name="Shape 168"/>
+        <p:cNvPr id="177" name="Shape 177"/>
         <p:cNvGrpSpPr/>
         <p:nvPr/>
       </p:nvGrpSpPr>
@@ -2719,7 +2719,7 @@
       </p:grpSpPr>
       <p:sp>
         <p:nvSpPr>
-          <p:cNvPr id="169" name="Google Shape;169;g3c4373e66a4_0_0:notes"/>
+          <p:cNvPr id="178" name="Google Shape;178;g3c4373e66a4_0_0:notes"/>
           <p:cNvSpPr/>
           <p:nvPr>
             <p:ph idx="2" type="sldImg"/>
@@ -2764,7 +2764,7 @@
       </p:sp>
       <p:sp>
         <p:nvSpPr>
-          <p:cNvPr id="170" name="Google Shape;170;g3c4373e66a4_0_0:notes"/>
+          <p:cNvPr id="179" name="Google Shape;179;g3c4373e66a4_0_0:notes"/>
           <p:cNvSpPr txBox="1"/>
           <p:nvPr>
             <p:ph idx="1" type="body"/>
@@ -2851,7 +2851,7 @@
       </p:sp>
       <p:sp>
         <p:nvSpPr>
-          <p:cNvPr id="171" name="Google Shape;171;g3c4373e66a4_0_0:notes"/>
+          <p:cNvPr id="180" name="Google Shape;180;g3c4373e66a4_0_0:notes"/>
           <p:cNvSpPr txBox="1"/>
           <p:nvPr>
             <p:ph idx="12" type="sldNum"/>
@@ -15648,8 +15648,8 @@
         </p:nvSpPr>
         <p:spPr>
           <a:xfrm>
-            <a:off x="495892" y="1180762"/>
-            <a:ext cx="6024769" cy="644870"/>
+            <a:off x="474367" y="1396062"/>
+            <a:ext cx="6024900" cy="645000"/>
           </a:xfrm>
           <a:prstGeom prst="rect">
             <a:avLst/>
@@ -15702,8 +15702,8 @@
         </p:nvSpPr>
         <p:spPr>
           <a:xfrm>
-            <a:off x="495893" y="3296297"/>
-            <a:ext cx="5051467" cy="1277273"/>
+            <a:off x="517443" y="2813247"/>
+            <a:ext cx="5051400" cy="1250700"/>
           </a:xfrm>
           <a:prstGeom prst="rect">
             <a:avLst/>
@@ -15866,7 +15866,27 @@
                 <a:cs typeface="Arial"/>
                 <a:sym typeface="Arial"/>
               </a:rPr>
-              <a:t>Rosane Meyer</a:t>
+              <a:t>Rosa</a:t>
+            </a:r>
+            <a:r>
+              <a:rPr lang="pt-BR" sz="1600">
+                <a:solidFill>
+                  <a:srgbClr val="1C3C5C"/>
+                </a:solidFill>
+              </a:rPr>
+              <a:t>na </a:t>
+            </a:r>
+            <a:r>
+              <a:rPr b="0" i="0" lang="pt-BR" sz="1600" u="none" cap="none" strike="noStrike">
+                <a:solidFill>
+                  <a:srgbClr val="1C3C5C"/>
+                </a:solidFill>
+                <a:latin typeface="Arial"/>
+                <a:ea typeface="Arial"/>
+                <a:cs typeface="Arial"/>
+                <a:sym typeface="Arial"/>
+              </a:rPr>
+              <a:t>Meyer</a:t>
             </a:r>
             <a:endParaRPr b="0" i="0" sz="1600" u="none" cap="none" strike="noStrike">
               <a:solidFill>
@@ -15897,16 +15917,12 @@
               <a:buNone/>
             </a:pPr>
             <a:r>
-              <a:rPr b="0" i="0" lang="pt-BR" sz="1600" u="none" cap="none" strike="noStrike">
+              <a:rPr lang="pt-BR" sz="1600">
                 <a:solidFill>
                   <a:srgbClr val="1C3C5C"/>
                 </a:solidFill>
-                <a:latin typeface="Arial"/>
-                <a:ea typeface="Arial"/>
-                <a:cs typeface="Arial"/>
-                <a:sym typeface="Arial"/>
               </a:rPr>
-              <a:t>Sandro Santos Jr.</a:t>
+              <a:t>Sandro R. S. Gonçalves Júnior</a:t>
             </a:r>
             <a:endParaRPr b="0" i="0" sz="1400" u="none" cap="none" strike="noStrike">
               <a:solidFill>
@@ -15928,8 +15944,8 @@
         </p:nvSpPr>
         <p:spPr>
           <a:xfrm>
-            <a:off x="495891" y="5390067"/>
-            <a:ext cx="6096000" cy="215444"/>
+            <a:off x="517441" y="4173167"/>
+            <a:ext cx="6096000" cy="431100"/>
           </a:xfrm>
           <a:prstGeom prst="rect">
             <a:avLst/>
@@ -15972,7 +15988,87 @@
                 <a:cs typeface="Arial"/>
                 <a:sym typeface="Arial"/>
               </a:rPr>
-              <a:t>Orientação: Prof.ª Ma. Izabel Cristina da Rosa dos Santos</a:t>
+              <a:t>Orientação: Prof.ª Ma. Izabel Cristina da Rosa dos Santos e </a:t>
+            </a:r>
+            <a:endParaRPr b="0" i="0" sz="1400" u="none" cap="none" strike="noStrike">
+              <a:solidFill>
+                <a:srgbClr val="CF5721"/>
+              </a:solidFill>
+              <a:latin typeface="Arial"/>
+              <a:ea typeface="Arial"/>
+              <a:cs typeface="Arial"/>
+              <a:sym typeface="Arial"/>
+            </a:endParaRPr>
+          </a:p>
+          <a:p>
+            <a:pPr indent="0" lvl="0" marL="0" marR="0" rtl="0" algn="l">
+              <a:lnSpc>
+                <a:spcPct val="100000"/>
+              </a:lnSpc>
+              <a:spcBef>
+                <a:spcPts val="0"/>
+              </a:spcBef>
+              <a:spcAft>
+                <a:spcPts val="0"/>
+              </a:spcAft>
+              <a:buClr>
+                <a:srgbClr val="000000"/>
+              </a:buClr>
+              <a:buSzPts val="1400"/>
+              <a:buFont typeface="Arial"/>
+              <a:buNone/>
+            </a:pPr>
+            <a:r>
+              <a:rPr b="0" i="0" lang="pt-BR" sz="1400" u="none" cap="none" strike="noStrike">
+                <a:solidFill>
+                  <a:srgbClr val="CF5721"/>
+                </a:solidFill>
+                <a:latin typeface="Arial"/>
+                <a:ea typeface="Arial"/>
+                <a:cs typeface="Arial"/>
+                <a:sym typeface="Arial"/>
+              </a:rPr>
+              <a:t>Mauricio dos </a:t>
+            </a:r>
+            <a:r>
+              <a:rPr lang="pt-BR">
+                <a:solidFill>
+                  <a:srgbClr val="CF5721"/>
+                </a:solidFill>
+              </a:rPr>
+              <a:t>S</a:t>
+            </a:r>
+            <a:r>
+              <a:rPr b="0" i="0" lang="pt-BR" sz="1400" u="none" cap="none" strike="noStrike">
+                <a:solidFill>
+                  <a:srgbClr val="CF5721"/>
+                </a:solidFill>
+                <a:latin typeface="Arial"/>
+                <a:ea typeface="Arial"/>
+                <a:cs typeface="Arial"/>
+                <a:sym typeface="Arial"/>
+              </a:rPr>
+              <a:t>antos </a:t>
+            </a:r>
+            <a:r>
+              <a:rPr lang="pt-BR">
+                <a:solidFill>
+                  <a:srgbClr val="CF5721"/>
+                </a:solidFill>
+              </a:rPr>
+              <a:t>F</a:t>
+            </a:r>
+            <a:r>
+              <a:rPr b="0" i="0" lang="pt-BR" sz="1400" u="none" cap="none" strike="noStrike">
+                <a:solidFill>
+                  <a:srgbClr val="CF5721"/>
+                </a:solidFill>
+                <a:latin typeface="Arial"/>
+                <a:ea typeface="Arial"/>
+                <a:cs typeface="Arial"/>
+                <a:sym typeface="Arial"/>
+              </a:rPr>
+              <a:t>erreira</a:t>
             </a:r>
             <a:endParaRPr b="0" i="0" sz="1400" u="none" cap="none" strike="noStrike">
               <a:solidFill>
@@ -15994,8 +16090,8 @@
         </p:nvSpPr>
         <p:spPr>
           <a:xfrm>
-            <a:off x="495891" y="1749172"/>
-            <a:ext cx="6024769" cy="644870"/>
+            <a:off x="474366" y="1964472"/>
+            <a:ext cx="6024900" cy="645000"/>
           </a:xfrm>
           <a:prstGeom prst="rect">
             <a:avLst/>
@@ -16094,21 +16190,22 @@
       </p:sp>
       <p:pic>
         <p:nvPicPr>
-          <p:cNvPr descr="Interface gráfica do usuário&#10;&#10;O conteúdo gerado por IA pode estar incorreto." id="94" name="Google Shape;94;p1"/>
+          <p:cNvPr id="94" name="Google Shape;94;p1" title="uni.png"/>
           <p:cNvPicPr preferRelativeResize="0"/>
           <p:nvPr/>
         </p:nvPicPr>
-        <p:blipFill rotWithShape="1">
+        <p:blipFill>
           <a:blip r:embed="rId3">
             <a:alphaModFix/>
           </a:blip>
-          <a:srcRect b="3288" l="1844" r="57030" t="3020"/>
-          <a:stretch/>
+          <a:stretch>
+            <a:fillRect/>
+          </a:stretch>
         </p:blipFill>
         <p:spPr>
           <a:xfrm>
-            <a:off x="6520661" y="531146"/>
-            <a:ext cx="4718470" cy="5795708"/>
+            <a:off x="687038" y="5215100"/>
+            <a:ext cx="2376052" cy="645000"/>
           </a:xfrm>
           <a:prstGeom prst="rect">
             <a:avLst/>
@@ -16119,6 +16216,180 @@
           </a:ln>
         </p:spPr>
       </p:pic>
+      <p:pic>
+        <p:nvPicPr>
+          <p:cNvPr id="95" name="Google Shape;95;p1"/>
+          <p:cNvPicPr preferRelativeResize="0"/>
+          <p:nvPr/>
+        </p:nvPicPr>
+        <p:blipFill>
+          <a:blip r:embed="rId4">
+            <a:alphaModFix/>
+          </a:blip>
+          <a:stretch>
+            <a:fillRect/>
+          </a:stretch>
+        </p:blipFill>
+        <p:spPr>
+          <a:xfrm>
+            <a:off x="-518994" y="5860100"/>
+            <a:ext cx="7581455" cy="901650"/>
+          </a:xfrm>
+          <a:prstGeom prst="rect">
+            <a:avLst/>
+          </a:prstGeom>
+          <a:noFill/>
+          <a:ln>
+            <a:noFill/>
+          </a:ln>
+        </p:spPr>
+      </p:pic>
+      <p:pic>
+        <p:nvPicPr>
+          <p:cNvPr id="96" name="Google Shape;96;p1"/>
+          <p:cNvPicPr preferRelativeResize="0"/>
+          <p:nvPr/>
+        </p:nvPicPr>
+        <p:blipFill>
+          <a:blip r:embed="rId5">
+            <a:alphaModFix/>
+          </a:blip>
+          <a:stretch>
+            <a:fillRect/>
+          </a:stretch>
+        </p:blipFill>
+        <p:spPr>
+          <a:xfrm>
+            <a:off x="3431187" y="5215100"/>
+            <a:ext cx="1881913" cy="645000"/>
+          </a:xfrm>
+          <a:prstGeom prst="rect">
+            <a:avLst/>
+          </a:prstGeom>
+          <a:noFill/>
+          <a:ln>
+            <a:noFill/>
+          </a:ln>
+        </p:spPr>
+      </p:pic>
+      <p:pic>
+        <p:nvPicPr>
+          <p:cNvPr id="97" name="Google Shape;97;p1" title="imagem-login.png"/>
+          <p:cNvPicPr preferRelativeResize="0"/>
+          <p:nvPr/>
+        </p:nvPicPr>
+        <p:blipFill>
+          <a:blip r:embed="rId6">
+            <a:alphaModFix/>
+          </a:blip>
+          <a:stretch>
+            <a:fillRect/>
+          </a:stretch>
+        </p:blipFill>
+        <p:spPr>
+          <a:xfrm>
+            <a:off x="7417672" y="0"/>
+            <a:ext cx="5925445" cy="6858000"/>
+          </a:xfrm>
+          <a:prstGeom prst="rect">
+            <a:avLst/>
+          </a:prstGeom>
+          <a:noFill/>
+          <a:ln>
+            <a:noFill/>
+          </a:ln>
+        </p:spPr>
+      </p:pic>
+      <p:pic>
+        <p:nvPicPr>
+          <p:cNvPr id="98" name="Google Shape;98;p1"/>
+          <p:cNvPicPr preferRelativeResize="0"/>
+          <p:nvPr/>
+        </p:nvPicPr>
+        <p:blipFill>
+          <a:blip r:embed="rId7">
+            <a:alphaModFix/>
+          </a:blip>
+          <a:stretch>
+            <a:fillRect/>
+          </a:stretch>
+        </p:blipFill>
+        <p:spPr>
+          <a:xfrm>
+            <a:off x="153350" y="90025"/>
+            <a:ext cx="2656966" cy="1375500"/>
+          </a:xfrm>
+          <a:prstGeom prst="rect">
+            <a:avLst/>
+          </a:prstGeom>
+          <a:noFill/>
+          <a:ln>
+            <a:noFill/>
+          </a:ln>
+        </p:spPr>
+      </p:pic>
+      <p:sp>
+        <p:nvSpPr>
+          <p:cNvPr id="99" name="Google Shape;99;p1"/>
+          <p:cNvSpPr txBox="1"/>
+          <p:nvPr/>
+        </p:nvSpPr>
+        <p:spPr>
+          <a:xfrm>
+            <a:off x="517441" y="4694130"/>
+            <a:ext cx="6096000" cy="215400"/>
+          </a:xfrm>
+          <a:prstGeom prst="rect">
+            <a:avLst/>
+          </a:prstGeom>
+          <a:noFill/>
+          <a:ln>
+            <a:noFill/>
+          </a:ln>
+        </p:spPr>
+        <p:txBody>
+          <a:bodyPr anchorCtr="0" anchor="t" bIns="0" lIns="0" spcFirstLastPara="1" rIns="0" wrap="square" tIns="0">
+            <a:spAutoFit/>
+          </a:bodyPr>
+          <a:lstStyle/>
+          <a:p>
+            <a:pPr indent="0" lvl="0" marL="0" marR="0" rtl="0" algn="l">
+              <a:lnSpc>
+                <a:spcPct val="100000"/>
+              </a:lnSpc>
+              <a:spcBef>
+                <a:spcPts val="0"/>
+              </a:spcBef>
+              <a:spcAft>
+                <a:spcPts val="0"/>
+              </a:spcAft>
+              <a:buClr>
+                <a:srgbClr val="000000"/>
+              </a:buClr>
+              <a:buSzPts val="1400"/>
+              <a:buFont typeface="Arial"/>
+              <a:buNone/>
+            </a:pPr>
+            <a:r>
+              <a:rPr lang="pt-BR">
+                <a:solidFill>
+                  <a:srgbClr val="CF5721"/>
+                </a:solidFill>
+              </a:rPr>
+              <a:t>Cliente: Paulo Fochi</a:t>
+            </a:r>
+            <a:endParaRPr b="0" i="0" sz="1400" u="none" cap="none" strike="noStrike">
+              <a:solidFill>
+                <a:srgbClr val="000000"/>
+              </a:solidFill>
+              <a:latin typeface="Arial"/>
+              <a:ea typeface="Arial"/>
+              <a:cs typeface="Arial"/>
+              <a:sym typeface="Arial"/>
+            </a:endParaRPr>
+          </a:p>
+        </p:txBody>
+      </p:sp>
     </p:spTree>
   </p:cSld>
   <p:clrMapOvr>
@@ -16132,7 +16403,7 @@
   <p:cSld>
     <p:spTree>
       <p:nvGrpSpPr>
-        <p:cNvPr id="99" name="Shape 99"/>
+        <p:cNvPr id="104" name="Shape 104"/>
         <p:cNvGrpSpPr/>
         <p:nvPr/>
       </p:nvGrpSpPr>
@@ -16146,7 +16417,7 @@
       </p:grpSpPr>
       <p:sp>
         <p:nvSpPr>
-          <p:cNvPr id="100" name="Google Shape;100;p2"/>
+          <p:cNvPr id="105" name="Google Shape;105;p2"/>
           <p:cNvSpPr txBox="1"/>
           <p:nvPr>
             <p:ph type="title"/>
@@ -16206,7 +16477,7 @@
       </p:sp>
       <p:grpSp>
         <p:nvGrpSpPr>
-          <p:cNvPr id="101" name="Google Shape;101;p2"/>
+          <p:cNvPr id="106" name="Google Shape;106;p2"/>
           <p:cNvGrpSpPr/>
           <p:nvPr/>
         </p:nvGrpSpPr>
@@ -16220,7 +16491,7 @@
         </p:grpSpPr>
         <p:sp>
           <p:nvSpPr>
-            <p:cNvPr id="102" name="Google Shape;102;p2"/>
+            <p:cNvPr id="107" name="Google Shape;107;p2"/>
             <p:cNvSpPr/>
             <p:nvPr/>
           </p:nvSpPr>
@@ -16291,7 +16562,7 @@
         </p:sp>
         <p:sp>
           <p:nvSpPr>
-            <p:cNvPr id="103" name="Google Shape;103;p2"/>
+            <p:cNvPr id="108" name="Google Shape;108;p2"/>
             <p:cNvSpPr/>
             <p:nvPr/>
           </p:nvSpPr>
@@ -16348,7 +16619,7 @@
         </p:sp>
         <p:sp>
           <p:nvSpPr>
-            <p:cNvPr id="104" name="Google Shape;104;p2"/>
+            <p:cNvPr id="109" name="Google Shape;109;p2"/>
             <p:cNvSpPr txBox="1"/>
             <p:nvPr/>
           </p:nvSpPr>
@@ -16454,7 +16725,7 @@
         </p:sp>
         <p:sp>
           <p:nvSpPr>
-            <p:cNvPr id="105" name="Google Shape;105;p2"/>
+            <p:cNvPr id="110" name="Google Shape;110;p2"/>
             <p:cNvSpPr/>
             <p:nvPr/>
           </p:nvSpPr>
@@ -16525,7 +16796,7 @@
         </p:sp>
         <p:sp>
           <p:nvSpPr>
-            <p:cNvPr id="106" name="Google Shape;106;p2"/>
+            <p:cNvPr id="111" name="Google Shape;111;p2"/>
             <p:cNvSpPr/>
             <p:nvPr/>
           </p:nvSpPr>
@@ -16582,7 +16853,7 @@
         </p:sp>
         <p:sp>
           <p:nvSpPr>
-            <p:cNvPr id="107" name="Google Shape;107;p2"/>
+            <p:cNvPr id="112" name="Google Shape;112;p2"/>
             <p:cNvSpPr txBox="1"/>
             <p:nvPr/>
           </p:nvSpPr>
@@ -16688,7 +16959,7 @@
         </p:sp>
         <p:sp>
           <p:nvSpPr>
-            <p:cNvPr id="108" name="Google Shape;108;p2"/>
+            <p:cNvPr id="113" name="Google Shape;113;p2"/>
             <p:cNvSpPr/>
             <p:nvPr/>
           </p:nvSpPr>
@@ -16759,7 +17030,7 @@
         </p:sp>
         <p:sp>
           <p:nvSpPr>
-            <p:cNvPr id="109" name="Google Shape;109;p2"/>
+            <p:cNvPr id="114" name="Google Shape;114;p2"/>
             <p:cNvSpPr/>
             <p:nvPr/>
           </p:nvSpPr>
@@ -16816,7 +17087,7 @@
         </p:sp>
         <p:sp>
           <p:nvSpPr>
-            <p:cNvPr id="110" name="Google Shape;110;p2"/>
+            <p:cNvPr id="115" name="Google Shape;115;p2"/>
             <p:cNvSpPr txBox="1"/>
             <p:nvPr/>
           </p:nvSpPr>
@@ -16937,7 +17208,7 @@
   <p:cSld>
     <p:spTree>
       <p:nvGrpSpPr>
-        <p:cNvPr id="115" name="Shape 115"/>
+        <p:cNvPr id="120" name="Shape 120"/>
         <p:cNvGrpSpPr/>
         <p:nvPr/>
       </p:nvGrpSpPr>
@@ -16951,7 +17222,7 @@
       </p:grpSpPr>
       <p:sp>
         <p:nvSpPr>
-          <p:cNvPr id="116" name="Google Shape;116;p3"/>
+          <p:cNvPr id="121" name="Google Shape;121;p3"/>
           <p:cNvSpPr txBox="1"/>
           <p:nvPr>
             <p:ph type="title"/>
@@ -17022,7 +17293,7 @@
       </p:sp>
       <p:grpSp>
         <p:nvGrpSpPr>
-          <p:cNvPr id="117" name="Google Shape;117;p3"/>
+          <p:cNvPr id="122" name="Google Shape;122;p3"/>
           <p:cNvGrpSpPr/>
           <p:nvPr/>
         </p:nvGrpSpPr>
@@ -17036,7 +17307,7 @@
         </p:grpSpPr>
         <p:grpSp>
           <p:nvGrpSpPr>
-            <p:cNvPr id="118" name="Google Shape;118;p3"/>
+            <p:cNvPr id="123" name="Google Shape;123;p3"/>
             <p:cNvGrpSpPr/>
             <p:nvPr/>
           </p:nvGrpSpPr>
@@ -17050,7 +17321,7 @@
           </p:grpSpPr>
           <p:sp>
             <p:nvSpPr>
-              <p:cNvPr id="119" name="Google Shape;119;p3"/>
+              <p:cNvPr id="124" name="Google Shape;124;p3"/>
               <p:cNvSpPr/>
               <p:nvPr/>
             </p:nvSpPr>
@@ -17111,7 +17382,7 @@
           </p:sp>
           <p:sp>
             <p:nvSpPr>
-              <p:cNvPr id="120" name="Google Shape;120;p3"/>
+              <p:cNvPr id="125" name="Google Shape;125;p3"/>
               <p:cNvSpPr/>
               <p:nvPr/>
             </p:nvSpPr>
@@ -17182,7 +17453,7 @@
           </p:sp>
           <p:sp>
             <p:nvSpPr>
-              <p:cNvPr id="121" name="Google Shape;121;p3"/>
+              <p:cNvPr id="126" name="Google Shape;126;p3"/>
               <p:cNvSpPr/>
               <p:nvPr/>
             </p:nvSpPr>
@@ -17239,7 +17510,7 @@
           </p:sp>
           <p:sp>
             <p:nvSpPr>
-              <p:cNvPr id="122" name="Google Shape;122;p3"/>
+              <p:cNvPr id="127" name="Google Shape;127;p3"/>
               <p:cNvSpPr txBox="1"/>
               <p:nvPr/>
             </p:nvSpPr>
@@ -17346,7 +17617,7 @@
         </p:grpSp>
         <p:grpSp>
           <p:nvGrpSpPr>
-            <p:cNvPr id="123" name="Google Shape;123;p3"/>
+            <p:cNvPr id="128" name="Google Shape;128;p3"/>
             <p:cNvGrpSpPr/>
             <p:nvPr/>
           </p:nvGrpSpPr>
@@ -17360,7 +17631,7 @@
           </p:grpSpPr>
           <p:sp>
             <p:nvSpPr>
-              <p:cNvPr id="124" name="Google Shape;124;p3"/>
+              <p:cNvPr id="129" name="Google Shape;129;p3"/>
               <p:cNvSpPr/>
               <p:nvPr/>
             </p:nvSpPr>
@@ -17421,7 +17692,7 @@
           </p:sp>
           <p:sp>
             <p:nvSpPr>
-              <p:cNvPr id="125" name="Google Shape;125;p3"/>
+              <p:cNvPr id="130" name="Google Shape;130;p3"/>
               <p:cNvSpPr/>
               <p:nvPr/>
             </p:nvSpPr>
@@ -17492,7 +17763,7 @@
           </p:sp>
           <p:sp>
             <p:nvSpPr>
-              <p:cNvPr id="126" name="Google Shape;126;p3"/>
+              <p:cNvPr id="131" name="Google Shape;131;p3"/>
               <p:cNvSpPr/>
               <p:nvPr/>
             </p:nvSpPr>
@@ -17549,7 +17820,7 @@
           </p:sp>
           <p:sp>
             <p:nvSpPr>
-              <p:cNvPr id="127" name="Google Shape;127;p3"/>
+              <p:cNvPr id="132" name="Google Shape;132;p3"/>
               <p:cNvSpPr txBox="1"/>
               <p:nvPr/>
             </p:nvSpPr>
@@ -17652,7 +17923,7 @@
       </p:grpSp>
       <p:pic>
         <p:nvPicPr>
-          <p:cNvPr descr="Interface gráfica do usuário, Aplicativo&#10;&#10;O conteúdo gerado por IA pode estar incorreto." id="128" name="Google Shape;128;p3"/>
+          <p:cNvPr descr="Interface gráfica do usuário, Aplicativo&#10;&#10;O conteúdo gerado por IA pode estar incorreto." id="133" name="Google Shape;133;p3"/>
           <p:cNvPicPr preferRelativeResize="0"/>
           <p:nvPr/>
         </p:nvPicPr>
@@ -17679,7 +17950,7 @@
       </p:pic>
       <p:pic>
         <p:nvPicPr>
-          <p:cNvPr descr="Desenho de um círculo&#10;&#10;O conteúdo gerado por IA pode estar incorreto." id="129" name="Google Shape;129;p3"/>
+          <p:cNvPr descr="Desenho de um círculo&#10;&#10;O conteúdo gerado por IA pode estar incorreto." id="134" name="Google Shape;134;p3"/>
           <p:cNvPicPr preferRelativeResize="0"/>
           <p:nvPr/>
         </p:nvPicPr>
@@ -17736,7 +18007,7 @@
     </p:bg>
     <p:spTree>
       <p:nvGrpSpPr>
-        <p:cNvPr id="134" name="Shape 134"/>
+        <p:cNvPr id="139" name="Shape 139"/>
         <p:cNvGrpSpPr/>
         <p:nvPr/>
       </p:nvGrpSpPr>
@@ -17750,7 +18021,7 @@
       </p:grpSpPr>
       <p:sp>
         <p:nvSpPr>
-          <p:cNvPr id="135" name="Google Shape;135;p4"/>
+          <p:cNvPr id="140" name="Google Shape;140;p4"/>
           <p:cNvSpPr txBox="1"/>
           <p:nvPr>
             <p:ph type="title"/>
@@ -17758,8 +18029,8 @@
         </p:nvSpPr>
         <p:spPr>
           <a:xfrm>
-            <a:off x="838200" y="557189"/>
-            <a:ext cx="3374136" cy="5567891"/>
+            <a:off x="827425" y="356800"/>
+            <a:ext cx="3737400" cy="3821400"/>
           </a:xfrm>
           <a:prstGeom prst="rect">
             <a:avLst/>
@@ -17810,13 +18081,13 @@
       </p:sp>
       <p:grpSp>
         <p:nvGrpSpPr>
-          <p:cNvPr id="136" name="Google Shape;136;p4"/>
+          <p:cNvPr id="141" name="Google Shape;141;p4"/>
           <p:cNvGrpSpPr/>
           <p:nvPr/>
         </p:nvGrpSpPr>
         <p:grpSpPr>
           <a:xfrm>
-            <a:off x="5090159" y="1516740"/>
+            <a:off x="5047109" y="806165"/>
             <a:ext cx="6263641" cy="3372029"/>
             <a:chOff x="5090159" y="1516740"/>
             <a:chExt cx="6263641" cy="3372029"/>
@@ -17824,7 +18095,7 @@
         </p:grpSpPr>
         <p:sp>
           <p:nvSpPr>
-            <p:cNvPr id="137" name="Google Shape;137;p4"/>
+            <p:cNvPr id="142" name="Google Shape;142;p4"/>
             <p:cNvSpPr/>
             <p:nvPr/>
           </p:nvSpPr>
@@ -17885,7 +18156,7 @@
         </p:sp>
         <p:sp>
           <p:nvSpPr>
-            <p:cNvPr id="138" name="Google Shape;138;p4"/>
+            <p:cNvPr id="143" name="Google Shape;143;p4"/>
             <p:cNvSpPr/>
             <p:nvPr/>
           </p:nvSpPr>
@@ -17949,7 +18220,7 @@
         </p:sp>
         <p:sp>
           <p:nvSpPr>
-            <p:cNvPr id="139" name="Google Shape;139;p4"/>
+            <p:cNvPr id="144" name="Google Shape;144;p4"/>
             <p:cNvSpPr/>
             <p:nvPr/>
           </p:nvSpPr>
@@ -18006,7 +18277,7 @@
         </p:sp>
         <p:sp>
           <p:nvSpPr>
-            <p:cNvPr id="140" name="Google Shape;140;p4"/>
+            <p:cNvPr id="145" name="Google Shape;145;p4"/>
             <p:cNvSpPr txBox="1"/>
             <p:nvPr/>
           </p:nvSpPr>
@@ -18072,7 +18343,7 @@
         </p:sp>
         <p:sp>
           <p:nvSpPr>
-            <p:cNvPr id="141" name="Google Shape;141;p4"/>
+            <p:cNvPr id="146" name="Google Shape;146;p4"/>
             <p:cNvSpPr/>
             <p:nvPr/>
           </p:nvSpPr>
@@ -18133,7 +18404,7 @@
         </p:sp>
         <p:sp>
           <p:nvSpPr>
-            <p:cNvPr id="142" name="Google Shape;142;p4"/>
+            <p:cNvPr id="147" name="Google Shape;147;p4"/>
             <p:cNvSpPr/>
             <p:nvPr/>
           </p:nvSpPr>
@@ -18197,7 +18468,7 @@
         </p:sp>
         <p:sp>
           <p:nvSpPr>
-            <p:cNvPr id="143" name="Google Shape;143;p4"/>
+            <p:cNvPr id="148" name="Google Shape;148;p4"/>
             <p:cNvSpPr/>
             <p:nvPr/>
           </p:nvSpPr>
@@ -18254,7 +18525,7 @@
         </p:sp>
         <p:sp>
           <p:nvSpPr>
-            <p:cNvPr id="144" name="Google Shape;144;p4"/>
+            <p:cNvPr id="149" name="Google Shape;149;p4"/>
             <p:cNvSpPr txBox="1"/>
             <p:nvPr/>
           </p:nvSpPr>
@@ -18320,7 +18591,7 @@
         </p:sp>
         <p:grpSp>
           <p:nvGrpSpPr>
-            <p:cNvPr id="145" name="Google Shape;145;p4"/>
+            <p:cNvPr id="150" name="Google Shape;150;p4"/>
             <p:cNvGrpSpPr/>
             <p:nvPr/>
           </p:nvGrpSpPr>
@@ -18334,7 +18605,7 @@
           </p:grpSpPr>
           <p:sp>
             <p:nvSpPr>
-              <p:cNvPr id="146" name="Google Shape;146;p4"/>
+              <p:cNvPr id="151" name="Google Shape;151;p4"/>
               <p:cNvSpPr/>
               <p:nvPr/>
             </p:nvSpPr>
@@ -18395,7 +18666,7 @@
           </p:sp>
           <p:sp>
             <p:nvSpPr>
-              <p:cNvPr id="147" name="Google Shape;147;p4"/>
+              <p:cNvPr id="152" name="Google Shape;152;p4"/>
               <p:cNvSpPr/>
               <p:nvPr/>
             </p:nvSpPr>
@@ -18459,7 +18730,7 @@
           </p:sp>
           <p:sp>
             <p:nvSpPr>
-              <p:cNvPr id="148" name="Google Shape;148;p4"/>
+              <p:cNvPr id="153" name="Google Shape;153;p4"/>
               <p:cNvSpPr/>
               <p:nvPr/>
             </p:nvSpPr>
@@ -18516,7 +18787,7 @@
           </p:sp>
           <p:sp>
             <p:nvSpPr>
-              <p:cNvPr id="149" name="Google Shape;149;p4"/>
+              <p:cNvPr id="154" name="Google Shape;154;p4"/>
               <p:cNvSpPr txBox="1"/>
               <p:nvPr/>
             </p:nvSpPr>
@@ -18582,6 +18853,268 @@
           </p:sp>
         </p:grpSp>
       </p:grpSp>
+      <p:sp>
+        <p:nvSpPr>
+          <p:cNvPr id="155" name="Google Shape;155;p4"/>
+          <p:cNvSpPr txBox="1"/>
+          <p:nvPr>
+            <p:ph type="title"/>
+          </p:nvPr>
+        </p:nvSpPr>
+        <p:spPr>
+          <a:xfrm>
+            <a:off x="827425" y="3710450"/>
+            <a:ext cx="3737400" cy="3821400"/>
+          </a:xfrm>
+          <a:prstGeom prst="rect">
+            <a:avLst/>
+          </a:prstGeom>
+          <a:noFill/>
+          <a:ln>
+            <a:noFill/>
+          </a:ln>
+        </p:spPr>
+        <p:txBody>
+          <a:bodyPr anchorCtr="0" anchor="ctr" bIns="45700" lIns="91425" spcFirstLastPara="1" rIns="91425" wrap="square" tIns="45700">
+            <a:normAutofit/>
+          </a:bodyPr>
+          <a:lstStyle/>
+          <a:p>
+            <a:pPr indent="0" lvl="0" marL="0" rtl="0" algn="l">
+              <a:lnSpc>
+                <a:spcPct val="90000"/>
+              </a:lnSpc>
+              <a:spcBef>
+                <a:spcPts val="0"/>
+              </a:spcBef>
+              <a:spcAft>
+                <a:spcPts val="0"/>
+              </a:spcAft>
+              <a:buClr>
+                <a:srgbClr val="1C3C5C"/>
+              </a:buClr>
+              <a:buSzPts val="3600"/>
+              <a:buFont typeface="Arial"/>
+              <a:buNone/>
+            </a:pPr>
+            <a:r>
+              <a:rPr b="1" lang="pt-BR" sz="3600">
+                <a:solidFill>
+                  <a:srgbClr val="1C3C5C"/>
+                </a:solidFill>
+                <a:latin typeface="Arial"/>
+                <a:ea typeface="Arial"/>
+                <a:cs typeface="Arial"/>
+                <a:sym typeface="Arial"/>
+              </a:rPr>
+              <a:t>Requisitos para implantação </a:t>
+            </a:r>
+            <a:endParaRPr/>
+          </a:p>
+        </p:txBody>
+      </p:sp>
+      <p:sp>
+        <p:nvSpPr>
+          <p:cNvPr id="156" name="Google Shape;156;p4"/>
+          <p:cNvSpPr/>
+          <p:nvPr/>
+        </p:nvSpPr>
+        <p:spPr>
+          <a:xfrm>
+            <a:off x="5047075" y="4997450"/>
+            <a:ext cx="6263700" cy="1247400"/>
+          </a:xfrm>
+          <a:prstGeom prst="roundRect">
+            <a:avLst>
+              <a:gd fmla="val 10000" name="adj"/>
+            </a:avLst>
+          </a:prstGeom>
+          <a:solidFill>
+            <a:schemeClr val="accent1"/>
+          </a:solidFill>
+          <a:ln>
+            <a:noFill/>
+          </a:ln>
+        </p:spPr>
+        <p:txBody>
+          <a:bodyPr anchorCtr="0" anchor="ctr" bIns="91425" lIns="91425" spcFirstLastPara="1" rIns="91425" wrap="square" tIns="91425">
+            <a:noAutofit/>
+          </a:bodyPr>
+          <a:lstStyle/>
+          <a:p>
+            <a:pPr indent="0" lvl="0" marL="0" marR="0" rtl="0" algn="l">
+              <a:lnSpc>
+                <a:spcPct val="100000"/>
+              </a:lnSpc>
+              <a:spcBef>
+                <a:spcPts val="0"/>
+              </a:spcBef>
+              <a:spcAft>
+                <a:spcPts val="0"/>
+              </a:spcAft>
+              <a:buClr>
+                <a:srgbClr val="000000"/>
+              </a:buClr>
+              <a:buSzPts val="1400"/>
+              <a:buFont typeface="Arial"/>
+              <a:buNone/>
+            </a:pPr>
+            <a:r>
+              <a:t/>
+            </a:r>
+            <a:endParaRPr b="0" i="0" sz="1400" u="none" cap="none" strike="noStrike">
+              <a:solidFill>
+                <a:srgbClr val="000000"/>
+              </a:solidFill>
+              <a:latin typeface="Arial"/>
+              <a:ea typeface="Arial"/>
+              <a:cs typeface="Arial"/>
+              <a:sym typeface="Arial"/>
+            </a:endParaRPr>
+          </a:p>
+        </p:txBody>
+      </p:sp>
+      <p:sp>
+        <p:nvSpPr>
+          <p:cNvPr id="157" name="Google Shape;157;p4"/>
+          <p:cNvSpPr txBox="1"/>
+          <p:nvPr/>
+        </p:nvSpPr>
+        <p:spPr>
+          <a:xfrm>
+            <a:off x="5836636" y="5196200"/>
+            <a:ext cx="5282100" cy="849900"/>
+          </a:xfrm>
+          <a:prstGeom prst="rect">
+            <a:avLst/>
+          </a:prstGeom>
+          <a:noFill/>
+          <a:ln>
+            <a:noFill/>
+          </a:ln>
+        </p:spPr>
+        <p:txBody>
+          <a:bodyPr anchorCtr="0" anchor="ctr" bIns="89925" lIns="89925" spcFirstLastPara="1" rIns="89925" wrap="square" tIns="89925">
+            <a:noAutofit/>
+          </a:bodyPr>
+          <a:lstStyle/>
+          <a:p>
+            <a:pPr indent="0" lvl="0" marL="0" marR="0" rtl="0" algn="l">
+              <a:lnSpc>
+                <a:spcPct val="100000"/>
+              </a:lnSpc>
+              <a:spcBef>
+                <a:spcPts val="0"/>
+              </a:spcBef>
+              <a:spcAft>
+                <a:spcPts val="0"/>
+              </a:spcAft>
+              <a:buClr>
+                <a:schemeClr val="dk1"/>
+              </a:buClr>
+              <a:buSzPts val="1900"/>
+              <a:buFont typeface="Arial"/>
+              <a:buNone/>
+            </a:pPr>
+            <a:r>
+              <a:rPr lang="pt-BR" sz="1900">
+                <a:solidFill>
+                  <a:schemeClr val="dk1"/>
+                </a:solidFill>
+              </a:rPr>
+              <a:t>Domínio</a:t>
+            </a:r>
+            <a:r>
+              <a:rPr lang="pt-BR" sz="1900">
+                <a:solidFill>
+                  <a:schemeClr val="dk1"/>
+                </a:solidFill>
+              </a:rPr>
+              <a:t> e um Host para hospedar a aplicação</a:t>
+            </a:r>
+            <a:endParaRPr b="0" i="0" sz="1400" u="none" cap="none" strike="noStrike">
+              <a:solidFill>
+                <a:srgbClr val="000000"/>
+              </a:solidFill>
+              <a:latin typeface="Arial"/>
+              <a:ea typeface="Arial"/>
+              <a:cs typeface="Arial"/>
+              <a:sym typeface="Arial"/>
+            </a:endParaRPr>
+          </a:p>
+        </p:txBody>
+      </p:sp>
+      <p:sp>
+        <p:nvSpPr>
+          <p:cNvPr id="158" name="Google Shape;158;p4"/>
+          <p:cNvSpPr/>
+          <p:nvPr/>
+        </p:nvSpPr>
+        <p:spPr>
+          <a:xfrm>
+            <a:off x="5191050" y="5282600"/>
+            <a:ext cx="645600" cy="677100"/>
+          </a:xfrm>
+          <a:prstGeom prst="rect">
+            <a:avLst/>
+          </a:prstGeom>
+          <a:blipFill rotWithShape="1">
+            <a:blip r:embed="rId6">
+              <a:alphaModFix/>
+            </a:blip>
+            <a:stretch>
+              <a:fillRect b="0" l="0" r="0" t="0"/>
+            </a:stretch>
+          </a:blipFill>
+          <a:ln>
+            <a:noFill/>
+          </a:ln>
+          <a:effectLst>
+            <a:outerShdw blurRad="57150" rotWithShape="0" algn="ctr" dir="5400000" dist="19050">
+              <a:srgbClr val="000000">
+                <a:alpha val="62750"/>
+              </a:srgbClr>
+            </a:outerShdw>
+          </a:effectLst>
+        </p:spPr>
+        <p:txBody>
+          <a:bodyPr anchorCtr="0" anchor="ctr" bIns="91425" lIns="91425" spcFirstLastPara="1" rIns="91425" wrap="square" tIns="91425">
+            <a:noAutofit/>
+          </a:bodyPr>
+          <a:lstStyle/>
+          <a:p>
+            <a:pPr indent="0" lvl="0" marL="0" marR="0" rtl="0" algn="l">
+              <a:lnSpc>
+                <a:spcPct val="100000"/>
+              </a:lnSpc>
+              <a:spcBef>
+                <a:spcPts val="0"/>
+              </a:spcBef>
+              <a:spcAft>
+                <a:spcPts val="0"/>
+              </a:spcAft>
+              <a:buClr>
+                <a:srgbClr val="000000"/>
+              </a:buClr>
+              <a:buSzPts val="1400"/>
+              <a:buFont typeface="Arial"/>
+              <a:buNone/>
+            </a:pPr>
+            <a:r>
+              <a:t/>
+            </a:r>
+            <a:endParaRPr b="0" i="0" sz="1400" u="none" cap="none" strike="noStrike">
+              <a:solidFill>
+                <a:srgbClr val="000000"/>
+              </a:solidFill>
+              <a:latin typeface="Arial"/>
+              <a:ea typeface="Arial"/>
+              <a:cs typeface="Arial"/>
+              <a:sym typeface="Arial"/>
+            </a:endParaRPr>
+          </a:p>
+        </p:txBody>
+      </p:sp>
     </p:spTree>
   </p:cSld>
   <p:clrMapOvr>
@@ -18595,7 +19128,7 @@
   <p:cSld>
     <p:spTree>
       <p:nvGrpSpPr>
-        <p:cNvPr id="154" name="Shape 154"/>
+        <p:cNvPr id="163" name="Shape 163"/>
         <p:cNvGrpSpPr/>
         <p:nvPr/>
       </p:nvGrpSpPr>
@@ -18609,7 +19142,7 @@
       </p:grpSpPr>
       <p:sp>
         <p:nvSpPr>
-          <p:cNvPr id="155" name="Google Shape;155;p5"/>
+          <p:cNvPr id="164" name="Google Shape;164;p5"/>
           <p:cNvSpPr txBox="1"/>
           <p:nvPr>
             <p:ph type="title"/>
@@ -18669,7 +19202,7 @@
       </p:sp>
       <p:grpSp>
         <p:nvGrpSpPr>
-          <p:cNvPr id="156" name="Google Shape;156;p5"/>
+          <p:cNvPr id="165" name="Google Shape;165;p5"/>
           <p:cNvGrpSpPr/>
           <p:nvPr/>
         </p:nvGrpSpPr>
@@ -18683,7 +19216,7 @@
         </p:grpSpPr>
         <p:sp>
           <p:nvSpPr>
-            <p:cNvPr id="157" name="Google Shape;157;p5"/>
+            <p:cNvPr id="166" name="Google Shape;166;p5"/>
             <p:cNvSpPr/>
             <p:nvPr/>
           </p:nvSpPr>
@@ -18751,7 +19284,7 @@
         </p:sp>
         <p:sp>
           <p:nvSpPr>
-            <p:cNvPr id="158" name="Google Shape;158;p5"/>
+            <p:cNvPr id="167" name="Google Shape;167;p5"/>
             <p:cNvSpPr txBox="1"/>
             <p:nvPr/>
           </p:nvSpPr>
@@ -18853,7 +19386,7 @@
       </p:grpSp>
       <p:pic>
         <p:nvPicPr>
-          <p:cNvPr descr="Interface gráfica do usuário, Texto, Aplicativo, chat ou mensagem de texto&#10;&#10;O conteúdo gerado por IA pode estar incorreto." id="159" name="Google Shape;159;p5"/>
+          <p:cNvPr descr="Interface gráfica do usuário, Texto, Aplicativo, chat ou mensagem de texto&#10;&#10;O conteúdo gerado por IA pode estar incorreto." id="168" name="Google Shape;168;p5"/>
           <p:cNvPicPr preferRelativeResize="0"/>
           <p:nvPr/>
         </p:nvPicPr>
@@ -18893,7 +19426,7 @@
       </p:pic>
       <p:pic>
         <p:nvPicPr>
-          <p:cNvPr descr="Interface gráfica do usuário, Aplicativo&#10;&#10;O conteúdo gerado por IA pode estar incorreto." id="160" name="Google Shape;160;p5"/>
+          <p:cNvPr descr="Interface gráfica do usuário, Aplicativo&#10;&#10;O conteúdo gerado por IA pode estar incorreto." id="169" name="Google Shape;169;p5"/>
           <p:cNvPicPr preferRelativeResize="0"/>
           <p:nvPr/>
         </p:nvPicPr>
@@ -18933,7 +19466,7 @@
       </p:pic>
       <p:sp>
         <p:nvSpPr>
-          <p:cNvPr id="161" name="Google Shape;161;p5"/>
+          <p:cNvPr id="170" name="Google Shape;170;p5"/>
           <p:cNvSpPr/>
           <p:nvPr/>
         </p:nvSpPr>
@@ -19010,7 +19543,7 @@
   <p:cSld>
     <p:spTree>
       <p:nvGrpSpPr>
-        <p:cNvPr id="166" name="Shape 166"/>
+        <p:cNvPr id="175" name="Shape 175"/>
         <p:cNvGrpSpPr/>
         <p:nvPr/>
       </p:nvGrpSpPr>
@@ -19024,7 +19557,7 @@
       </p:grpSpPr>
       <p:pic>
         <p:nvPicPr>
-          <p:cNvPr id="167" name="Google Shape;167;g3c425a62f68_0_0" title="Plataforma Obeci.mp4">
+          <p:cNvPr id="176" name="Google Shape;176;g3c425a62f68_0_0" title="Plataforma Obeci.mp4">
             <a:hlinkClick r:id="rId3"/>
           </p:cNvPr>
           <p:cNvPicPr preferRelativeResize="0"/>
@@ -19094,7 +19627,7 @@
                                           </p:stCondLst>
                                         </p:cTn>
                                         <p:tgtEl>
-                                          <p:spTgt spid="167"/>
+                                          <p:spTgt spid="176"/>
                                         </p:tgtEl>
                                         <p:attrNameLst>
                                           <p:attrName>style.visibility</p:attrName>
@@ -19108,7 +19641,7 @@
                                       <p:cBhvr>
                                         <p:cTn dur="1000"/>
                                         <p:tgtEl>
-                                          <p:spTgt spid="167"/>
+                                          <p:spTgt spid="176"/>
                                         </p:tgtEl>
                                       </p:cBhvr>
                                     </p:animEffect>
@@ -19151,7 +19684,7 @@
   <p:cSld>
     <p:spTree>
       <p:nvGrpSpPr>
-        <p:cNvPr id="172" name="Shape 172"/>
+        <p:cNvPr id="181" name="Shape 181"/>
         <p:cNvGrpSpPr/>
         <p:nvPr/>
       </p:nvGrpSpPr>
@@ -19165,7 +19698,7 @@
       </p:grpSpPr>
       <p:sp>
         <p:nvSpPr>
-          <p:cNvPr id="173" name="Google Shape;173;g3c4373e66a4_0_0"/>
+          <p:cNvPr id="182" name="Google Shape;182;g3c4373e66a4_0_0"/>
           <p:cNvSpPr txBox="1"/>
           <p:nvPr>
             <p:ph type="title"/>
@@ -19186,11 +19719,113 @@
         </p:spPr>
         <p:txBody>
           <a:bodyPr anchorCtr="0" anchor="ctr" bIns="45700" lIns="91425" spcFirstLastPara="1" rIns="91425" wrap="square" tIns="45700">
-            <a:normAutofit/>
+            <a:normAutofit fontScale="90000"/>
           </a:bodyPr>
           <a:lstStyle/>
           <a:p>
             <a:pPr indent="0" lvl="0" marL="0" rtl="0" algn="ctr">
+              <a:spcBef>
+                <a:spcPts val="0"/>
+              </a:spcBef>
+              <a:spcAft>
+                <a:spcPts val="0"/>
+              </a:spcAft>
+              <a:buClr>
+                <a:schemeClr val="dk1"/>
+              </a:buClr>
+              <a:buSzPct val="27500"/>
+              <a:buFont typeface="Arial"/>
+              <a:buNone/>
+            </a:pPr>
+            <a:r>
+              <a:rPr b="1" lang="pt-BR" sz="4000">
+                <a:solidFill>
+                  <a:srgbClr val="1C3C5C"/>
+                </a:solidFill>
+                <a:latin typeface="Arial"/>
+                <a:ea typeface="Arial"/>
+                <a:cs typeface="Arial"/>
+                <a:sym typeface="Arial"/>
+              </a:rPr>
+              <a:t>Investir em nossa plataforma é garantir crescimento contínuo.</a:t>
+            </a:r>
+            <a:endParaRPr b="1" sz="4000">
+              <a:solidFill>
+                <a:srgbClr val="1C3C5C"/>
+              </a:solidFill>
+              <a:latin typeface="Arial"/>
+              <a:ea typeface="Arial"/>
+              <a:cs typeface="Arial"/>
+              <a:sym typeface="Arial"/>
+            </a:endParaRPr>
+          </a:p>
+          <a:p>
+            <a:pPr indent="0" lvl="0" marL="0" rtl="0" algn="ctr">
+              <a:spcBef>
+                <a:spcPts val="0"/>
+              </a:spcBef>
+              <a:spcAft>
+                <a:spcPts val="0"/>
+              </a:spcAft>
+              <a:buClr>
+                <a:schemeClr val="dk1"/>
+              </a:buClr>
+              <a:buSzPct val="27500"/>
+              <a:buFont typeface="Arial"/>
+              <a:buNone/>
+            </a:pPr>
+            <a:r>
+              <a:rPr b="1" lang="pt-BR" sz="4000">
+                <a:solidFill>
+                  <a:srgbClr val="1C3C5C"/>
+                </a:solidFill>
+                <a:latin typeface="Arial"/>
+                <a:ea typeface="Arial"/>
+                <a:cs typeface="Arial"/>
+                <a:sym typeface="Arial"/>
+              </a:rPr>
+              <a:t>Mais que ensino, resultados que fazem diferença.</a:t>
+            </a:r>
+            <a:endParaRPr b="1" sz="4000">
+              <a:solidFill>
+                <a:srgbClr val="1C3C5C"/>
+              </a:solidFill>
+              <a:latin typeface="Arial"/>
+              <a:ea typeface="Arial"/>
+              <a:cs typeface="Arial"/>
+              <a:sym typeface="Arial"/>
+            </a:endParaRPr>
+          </a:p>
+          <a:p>
+            <a:pPr indent="0" lvl="0" marL="0" rtl="0" algn="ctr">
+              <a:spcBef>
+                <a:spcPts val="0"/>
+              </a:spcBef>
+              <a:spcAft>
+                <a:spcPts val="0"/>
+              </a:spcAft>
+              <a:buClr>
+                <a:schemeClr val="dk1"/>
+              </a:buClr>
+              <a:buSzPct val="27500"/>
+              <a:buFont typeface="Arial"/>
+              <a:buNone/>
+            </a:pPr>
+            <a:r>
+              <a:t/>
+            </a:r>
+            <a:endParaRPr b="1" sz="4000">
+              <a:solidFill>
+                <a:srgbClr val="1C3C5C"/>
+              </a:solidFill>
+              <a:latin typeface="Arial"/>
+              <a:ea typeface="Arial"/>
+              <a:cs typeface="Arial"/>
+              <a:sym typeface="Arial"/>
+            </a:endParaRPr>
+          </a:p>
+          <a:p>
+            <a:pPr indent="0" lvl="0" marL="0" rtl="0" algn="ctr">
               <a:lnSpc>
                 <a:spcPct val="90000"/>
               </a:lnSpc>
@@ -19203,7 +19838,7 @@
               <a:buClr>
                 <a:srgbClr val="1C3C5C"/>
               </a:buClr>
-              <a:buSzPts val="4000"/>
+              <a:buSzPct val="100000"/>
               <a:buFont typeface="Arial"/>
               <a:buNone/>
             </a:pPr>

</xml_diff>